<commit_message>
Add faculty name (Sreeja B P) to report and presentation
Co-Authored-By: Claude Sonnet 5.5 <noreply@anthropic.com>
</commit_message>
<xml_diff>
--- a/presentation/Final_Project_Presentation.pptx
+++ b/presentation/Final_Project_Presentation.pptx
@@ -5422,12 +5422,12 @@
           <a:lstStyle/>
           <a:p>
             <a:r>
-              <a:rPr sz="1400" b="0" i="0">
-                <a:solidFill>
-                  <a:srgbClr val="C9342B"/>
-                </a:solidFill>
-              </a:rPr>
-              <a:t>[ enter faculty name ]</a:t>
+              <a:rPr sz="1400" b="1" i="0">
+                <a:solidFill>
+                  <a:srgbClr val="1A1A1A"/>
+                </a:solidFill>
+              </a:rPr>
+              <a:t>Sreeja B P</a:t>
             </a:r>
           </a:p>
         </p:txBody>

</xml_diff>